<commit_message>
updates for holistic course
</commit_message>
<xml_diff>
--- a/1.02IntroductionToHtmlElements/BasicHtmlElements.pptx
+++ b/1.02IntroductionToHtmlElements/BasicHtmlElements.pptx
@@ -5023,7 +5023,7 @@
           <a:p>
             <a:fld id="{5958763E-B898-436D-883D-03711491D54A}" type="datetimeFigureOut">
               <a:rPr lang="en-US" smtClean="0"/>
-              <a:t>1/30/2026</a:t>
+              <a:t>6/8/2026</a:t>
             </a:fld>
             <a:endParaRPr lang="en-US"/>
           </a:p>
@@ -8140,20 +8140,11 @@
           </a:bodyPr>
           <a:lstStyle/>
           <a:p>
-            <a:pPr marL="0" lvl="0" indent="0" algn="l" rtl="0">
-              <a:spcBef>
-                <a:spcPts val="0"/>
-              </a:spcBef>
-              <a:spcAft>
-                <a:spcPts val="0"/>
-              </a:spcAft>
-              <a:buNone/>
-            </a:pPr>
-            <a:r>
-              <a:rPr lang="en" dirty="0"/>
-              <a:t>Hy-Tech Club: Web 101</a:t>
-            </a:r>
-            <a:endParaRPr dirty="0"/>
+            <a:r>
+              <a:rPr lang="en-US"/>
+              <a:t>HTO: Website Development</a:t>
+            </a:r>
+            <a:endParaRPr lang="en-US" dirty="0"/>
           </a:p>
         </p:txBody>
       </p:sp>

</xml_diff>

<commit_message>
Update gitbook 2026-06-08 18:38:51
</commit_message>
<xml_diff>
--- a/1.02IntroductionToHtmlElements/BasicHtmlElements.pptx
+++ b/1.02IntroductionToHtmlElements/BasicHtmlElements.pptx
@@ -5023,7 +5023,7 @@
           <a:p>
             <a:fld id="{5958763E-B898-436D-883D-03711491D54A}" type="datetimeFigureOut">
               <a:rPr lang="en-US" smtClean="0"/>
-              <a:t>1/30/2026</a:t>
+              <a:t>6/8/2026</a:t>
             </a:fld>
             <a:endParaRPr lang="en-US"/>
           </a:p>
@@ -8140,20 +8140,11 @@
           </a:bodyPr>
           <a:lstStyle/>
           <a:p>
-            <a:pPr marL="0" lvl="0" indent="0" algn="l" rtl="0">
-              <a:spcBef>
-                <a:spcPts val="0"/>
-              </a:spcBef>
-              <a:spcAft>
-                <a:spcPts val="0"/>
-              </a:spcAft>
-              <a:buNone/>
-            </a:pPr>
-            <a:r>
-              <a:rPr lang="en" dirty="0"/>
-              <a:t>Hy-Tech Club: Web 101</a:t>
-            </a:r>
-            <a:endParaRPr dirty="0"/>
+            <a:r>
+              <a:rPr lang="en-US"/>
+              <a:t>HTO: Website Development</a:t>
+            </a:r>
+            <a:endParaRPr lang="en-US" dirty="0"/>
           </a:p>
         </p:txBody>
       </p:sp>

</xml_diff>